<commit_message>
update arrumando imagem cortada
</commit_message>
<xml_diff>
--- a/Aula 06/ComandosDCL.pptx
+++ b/Aula 06/ComandosDCL.pptx
@@ -3161,7 +3161,7 @@
         <p:spPr>
           <a:xfrm rot="0">
             <a:off x="249698" y="131445"/>
-            <a:ext cx="5725554" cy="871452"/>
+            <a:ext cx="5844894" cy="809625"/>
           </a:xfrm>
           <a:prstGeom prst="rect">
             <a:avLst/>
@@ -3243,7 +3243,7 @@
         <p:spPr>
           <a:xfrm rot="0">
             <a:off x="249698" y="8164087"/>
-            <a:ext cx="4855112" cy="1094213"/>
+            <a:ext cx="5530677" cy="1038225"/>
           </a:xfrm>
           <a:prstGeom prst="rect">
             <a:avLst/>
@@ -7657,10 +7657,10 @@
         </p:nvGrpSpPr>
         <p:grpSpPr>
           <a:xfrm rot="0">
-            <a:off x="0" y="0"/>
-            <a:ext cx="18288000" cy="10287000"/>
+            <a:off x="2932565" y="7365048"/>
+            <a:ext cx="5446430" cy="2821795"/>
             <a:chOff x="0" y="0"/>
-            <a:chExt cx="24384000" cy="13716000"/>
+            <a:chExt cx="26473655" cy="13716000"/>
           </a:xfrm>
         </p:grpSpPr>
         <p:sp>
@@ -7672,7 +7672,7 @@
           <p:spPr>
             <a:xfrm flipH="false" flipV="false" rot="0">
               <a:off x="0" y="0"/>
-              <a:ext cx="24384000" cy="13716000"/>
+              <a:ext cx="26473655" cy="13716000"/>
             </a:xfrm>
             <a:custGeom>
               <a:avLst/>
@@ -7681,15 +7681,15 @@
               <a:cxnLst/>
               <a:rect r="r" b="b" t="t" l="l"/>
               <a:pathLst>
-                <a:path h="13716000" w="24384000">
+                <a:path h="13716000" w="26473655">
                   <a:moveTo>
                     <a:pt x="0" y="0"/>
                   </a:moveTo>
                   <a:lnTo>
-                    <a:pt x="24384000" y="0"/>
-                  </a:lnTo>
-                  <a:lnTo>
-                    <a:pt x="24384000" y="13716000"/>
+                    <a:pt x="26473655" y="0"/>
+                  </a:lnTo>
+                  <a:lnTo>
+                    <a:pt x="26473655" y="13716000"/>
                   </a:lnTo>
                   <a:lnTo>
                     <a:pt x="0" y="13716000"/>
@@ -7704,7 +7704,7 @@
             <a:blipFill>
               <a:blip r:embed="rId2"/>
               <a:stretch>
-                <a:fillRect l="0" t="0" r="0" b="0"/>
+                <a:fillRect l="0" t="-104" r="0" b="-104"/>
               </a:stretch>
             </a:blipFill>
           </p:spPr>
@@ -7957,67 +7957,6 @@
               <a:blip r:embed="rId3"/>
               <a:stretch>
                 <a:fillRect l="0" t="0" r="0" b="0"/>
-              </a:stretch>
-            </a:blipFill>
-          </p:spPr>
-        </p:sp>
-      </p:grpSp>
-      <p:grpSp>
-        <p:nvGrpSpPr>
-          <p:cNvPr name="Group 8" id="8"/>
-          <p:cNvGrpSpPr/>
-          <p:nvPr/>
-        </p:nvGrpSpPr>
-        <p:grpSpPr>
-          <a:xfrm rot="0">
-            <a:off x="2565864" y="7650442"/>
-            <a:ext cx="7331364" cy="2504370"/>
-            <a:chOff x="0" y="0"/>
-            <a:chExt cx="9775152" cy="3339160"/>
-          </a:xfrm>
-        </p:grpSpPr>
-        <p:sp>
-          <p:nvSpPr>
-            <p:cNvPr name="Freeform 9" id="9"/>
-            <p:cNvSpPr/>
-            <p:nvPr/>
-          </p:nvSpPr>
-          <p:spPr>
-            <a:xfrm flipH="false" flipV="false" rot="0">
-              <a:off x="0" y="0"/>
-              <a:ext cx="9775190" cy="3339211"/>
-            </a:xfrm>
-            <a:custGeom>
-              <a:avLst/>
-              <a:gdLst/>
-              <a:ahLst/>
-              <a:cxnLst/>
-              <a:rect r="r" b="b" t="t" l="l"/>
-              <a:pathLst>
-                <a:path h="3339211" w="9775190">
-                  <a:moveTo>
-                    <a:pt x="0" y="0"/>
-                  </a:moveTo>
-                  <a:lnTo>
-                    <a:pt x="9775190" y="0"/>
-                  </a:lnTo>
-                  <a:lnTo>
-                    <a:pt x="9775190" y="3339211"/>
-                  </a:lnTo>
-                  <a:lnTo>
-                    <a:pt x="0" y="3339211"/>
-                  </a:lnTo>
-                  <a:lnTo>
-                    <a:pt x="0" y="0"/>
-                  </a:lnTo>
-                  <a:close/>
-                </a:path>
-              </a:pathLst>
-            </a:custGeom>
-            <a:blipFill>
-              <a:blip r:embed="rId4"/>
-              <a:stretch>
-                <a:fillRect l="0" t="-25993" r="0" b="-25991"/>
               </a:stretch>
             </a:blipFill>
           </p:spPr>

</xml_diff>